<commit_message>
update diagram and recipe build
</commit_message>
<xml_diff>
--- a/collateral/portal-apps-diagrams.pptx
+++ b/collateral/portal-apps-diagrams.pptx
@@ -105,6 +105,11 @@
       </a:defRPr>
     </a:lvl9pPr>
   </p:defaultTextStyle>
+  <p:extLst>
+    <p:ext uri="{EFAFB233-063F-42B5-8137-9DF3F51BA10A}">
+      <p15:sldGuideLst xmlns:p15="http://schemas.microsoft.com/office/powerpoint/2012/main"/>
+    </p:ext>
+  </p:extLst>
 </p:presentation>
 </file>
 
@@ -255,7 +260,7 @@
           <a:p>
             <a:fld id="{4BFAFCBD-C71C-4163-8EE4-8074804E40E4}" type="datetimeFigureOut">
               <a:rPr lang="en-US" smtClean="0"/>
-              <a:t>2/4/2026</a:t>
+              <a:t>5/27/2026</a:t>
             </a:fld>
             <a:endParaRPr lang="en-US"/>
           </a:p>
@@ -453,7 +458,7 @@
           <a:p>
             <a:fld id="{4BFAFCBD-C71C-4163-8EE4-8074804E40E4}" type="datetimeFigureOut">
               <a:rPr lang="en-US" smtClean="0"/>
-              <a:t>2/4/2026</a:t>
+              <a:t>5/27/2026</a:t>
             </a:fld>
             <a:endParaRPr lang="en-US"/>
           </a:p>
@@ -661,7 +666,7 @@
           <a:p>
             <a:fld id="{4BFAFCBD-C71C-4163-8EE4-8074804E40E4}" type="datetimeFigureOut">
               <a:rPr lang="en-US" smtClean="0"/>
-              <a:t>2/4/2026</a:t>
+              <a:t>5/27/2026</a:t>
             </a:fld>
             <a:endParaRPr lang="en-US"/>
           </a:p>
@@ -859,7 +864,7 @@
           <a:p>
             <a:fld id="{4BFAFCBD-C71C-4163-8EE4-8074804E40E4}" type="datetimeFigureOut">
               <a:rPr lang="en-US" smtClean="0"/>
-              <a:t>2/4/2026</a:t>
+              <a:t>5/27/2026</a:t>
             </a:fld>
             <a:endParaRPr lang="en-US"/>
           </a:p>
@@ -1134,7 +1139,7 @@
           <a:p>
             <a:fld id="{4BFAFCBD-C71C-4163-8EE4-8074804E40E4}" type="datetimeFigureOut">
               <a:rPr lang="en-US" smtClean="0"/>
-              <a:t>2/4/2026</a:t>
+              <a:t>5/27/2026</a:t>
             </a:fld>
             <a:endParaRPr lang="en-US"/>
           </a:p>
@@ -1399,7 +1404,7 @@
           <a:p>
             <a:fld id="{4BFAFCBD-C71C-4163-8EE4-8074804E40E4}" type="datetimeFigureOut">
               <a:rPr lang="en-US" smtClean="0"/>
-              <a:t>2/4/2026</a:t>
+              <a:t>5/27/2026</a:t>
             </a:fld>
             <a:endParaRPr lang="en-US"/>
           </a:p>
@@ -1811,7 +1816,7 @@
           <a:p>
             <a:fld id="{4BFAFCBD-C71C-4163-8EE4-8074804E40E4}" type="datetimeFigureOut">
               <a:rPr lang="en-US" smtClean="0"/>
-              <a:t>2/4/2026</a:t>
+              <a:t>5/27/2026</a:t>
             </a:fld>
             <a:endParaRPr lang="en-US"/>
           </a:p>
@@ -1952,7 +1957,7 @@
           <a:p>
             <a:fld id="{4BFAFCBD-C71C-4163-8EE4-8074804E40E4}" type="datetimeFigureOut">
               <a:rPr lang="en-US" smtClean="0"/>
-              <a:t>2/4/2026</a:t>
+              <a:t>5/27/2026</a:t>
             </a:fld>
             <a:endParaRPr lang="en-US"/>
           </a:p>
@@ -2065,7 +2070,7 @@
           <a:p>
             <a:fld id="{4BFAFCBD-C71C-4163-8EE4-8074804E40E4}" type="datetimeFigureOut">
               <a:rPr lang="en-US" smtClean="0"/>
-              <a:t>2/4/2026</a:t>
+              <a:t>5/27/2026</a:t>
             </a:fld>
             <a:endParaRPr lang="en-US"/>
           </a:p>
@@ -2376,7 +2381,7 @@
           <a:p>
             <a:fld id="{4BFAFCBD-C71C-4163-8EE4-8074804E40E4}" type="datetimeFigureOut">
               <a:rPr lang="en-US" smtClean="0"/>
-              <a:t>2/4/2026</a:t>
+              <a:t>5/27/2026</a:t>
             </a:fld>
             <a:endParaRPr lang="en-US"/>
           </a:p>
@@ -2664,7 +2669,7 @@
           <a:p>
             <a:fld id="{4BFAFCBD-C71C-4163-8EE4-8074804E40E4}" type="datetimeFigureOut">
               <a:rPr lang="en-US" smtClean="0"/>
-              <a:t>2/4/2026</a:t>
+              <a:t>5/27/2026</a:t>
             </a:fld>
             <a:endParaRPr lang="en-US"/>
           </a:p>
@@ -2905,7 +2910,7 @@
           <a:p>
             <a:fld id="{4BFAFCBD-C71C-4163-8EE4-8074804E40E4}" type="datetimeFigureOut">
               <a:rPr lang="en-US" smtClean="0"/>
-              <a:t>2/4/2026</a:t>
+              <a:t>5/27/2026</a:t>
             </a:fld>
             <a:endParaRPr lang="en-US"/>
           </a:p>
@@ -4107,13 +4112,13 @@
           <p:nvPr/>
         </p:nvPicPr>
         <p:blipFill>
-          <a:blip r:embed="rId4">
+          <a:blip>
             <a:extLst>
               <a:ext uri="{96DAC541-7B7A-43D3-8B79-37D633B846F1}">
-                <asvg:svgBlip xmlns:asvg="http://schemas.microsoft.com/office/drawing/2016/SVG/main" r:embed="rId5"/>
+                <asvg:svgBlip xmlns:asvg="http://schemas.microsoft.com/office/drawing/2016/SVG/main" r:embed="rId4"/>
               </a:ext>
               <a:ext uri="{837473B0-CC2E-450A-ABE3-18F120FF3D39}">
-                <a1611:picAttrSrcUrl xmlns:a1611="http://schemas.microsoft.com/office/drawing/2016/11/main" r:id="rId6"/>
+                <a1611:picAttrSrcUrl xmlns:a1611="http://schemas.microsoft.com/office/drawing/2016/11/main" r:id="rId5"/>
               </a:ext>
             </a:extLst>
           </a:blip>
@@ -4137,6 +4142,66 @@
             <a:extLst>
               <a:ext uri="{FF2B5EF4-FFF2-40B4-BE49-F238E27FC236}">
                 <a16:creationId xmlns:a16="http://schemas.microsoft.com/office/drawing/2014/main" id="{D0F9E5CD-729D-8F0A-AD10-B87B34025AED}"/>
+              </a:ext>
+            </a:extLst>
+          </p:cNvPr>
+          <p:cNvPicPr>
+            <a:picLocks noChangeAspect="1"/>
+          </p:cNvPicPr>
+          <p:nvPr/>
+        </p:nvPicPr>
+        <p:blipFill>
+          <a:blip r:embed="rId6"/>
+          <a:stretch>
+            <a:fillRect/>
+          </a:stretch>
+        </p:blipFill>
+        <p:spPr>
+          <a:xfrm>
+            <a:off x="3646258" y="3892762"/>
+            <a:ext cx="545815" cy="512623"/>
+          </a:xfrm>
+          <a:prstGeom prst="rect">
+            <a:avLst/>
+          </a:prstGeom>
+        </p:spPr>
+      </p:pic>
+      <p:pic>
+        <p:nvPicPr>
+          <p:cNvPr id="33" name="Picture 32">
+            <a:extLst>
+              <a:ext uri="{FF2B5EF4-FFF2-40B4-BE49-F238E27FC236}">
+                <a16:creationId xmlns:a16="http://schemas.microsoft.com/office/drawing/2014/main" id="{944ACEB1-EC62-4D76-BAE1-879EE8779FB1}"/>
+              </a:ext>
+            </a:extLst>
+          </p:cNvPr>
+          <p:cNvPicPr>
+            <a:picLocks noChangeAspect="1"/>
+          </p:cNvPicPr>
+          <p:nvPr/>
+        </p:nvPicPr>
+        <p:blipFill>
+          <a:blip r:embed="rId6"/>
+          <a:stretch>
+            <a:fillRect/>
+          </a:stretch>
+        </p:blipFill>
+        <p:spPr>
+          <a:xfrm>
+            <a:off x="3011394" y="2842334"/>
+            <a:ext cx="393415" cy="369491"/>
+          </a:xfrm>
+          <a:prstGeom prst="rect">
+            <a:avLst/>
+          </a:prstGeom>
+        </p:spPr>
+      </p:pic>
+      <p:pic>
+        <p:nvPicPr>
+          <p:cNvPr id="39" name="Picture 38" descr="File:Visual Studio Code 1.35 icon.svg - Wikimedia Commons">
+            <a:extLst>
+              <a:ext uri="{FF2B5EF4-FFF2-40B4-BE49-F238E27FC236}">
+                <a16:creationId xmlns:a16="http://schemas.microsoft.com/office/drawing/2014/main" id="{5DEE6865-6030-8BA1-FD5F-BAE0D64EEC63}"/>
               </a:ext>
             </a:extLst>
           </p:cNvPr>
@@ -4147,105 +4212,6 @@
         </p:nvPicPr>
         <p:blipFill>
           <a:blip r:embed="rId7"/>
-          <a:stretch>
-            <a:fillRect/>
-          </a:stretch>
-        </p:blipFill>
-        <p:spPr>
-          <a:xfrm>
-            <a:off x="3646258" y="3892762"/>
-            <a:ext cx="545815" cy="512623"/>
-          </a:xfrm>
-          <a:prstGeom prst="rect">
-            <a:avLst/>
-          </a:prstGeom>
-        </p:spPr>
-      </p:pic>
-      <p:pic>
-        <p:nvPicPr>
-          <p:cNvPr id="33" name="Picture 32">
-            <a:extLst>
-              <a:ext uri="{FF2B5EF4-FFF2-40B4-BE49-F238E27FC236}">
-                <a16:creationId xmlns:a16="http://schemas.microsoft.com/office/drawing/2014/main" id="{944ACEB1-EC62-4D76-BAE1-879EE8779FB1}"/>
-              </a:ext>
-            </a:extLst>
-          </p:cNvPr>
-          <p:cNvPicPr>
-            <a:picLocks noChangeAspect="1"/>
-          </p:cNvPicPr>
-          <p:nvPr/>
-        </p:nvPicPr>
-        <p:blipFill>
-          <a:blip r:embed="rId7"/>
-          <a:stretch>
-            <a:fillRect/>
-          </a:stretch>
-        </p:blipFill>
-        <p:spPr>
-          <a:xfrm>
-            <a:off x="3011394" y="2842334"/>
-            <a:ext cx="393415" cy="369491"/>
-          </a:xfrm>
-          <a:prstGeom prst="rect">
-            <a:avLst/>
-          </a:prstGeom>
-        </p:spPr>
-      </p:pic>
-      <p:pic>
-        <p:nvPicPr>
-          <p:cNvPr id="35" name="Picture 34">
-            <a:extLst>
-              <a:ext uri="{FF2B5EF4-FFF2-40B4-BE49-F238E27FC236}">
-                <a16:creationId xmlns:a16="http://schemas.microsoft.com/office/drawing/2014/main" id="{558F8D34-302E-5D3A-75C0-D302F679A35D}"/>
-              </a:ext>
-            </a:extLst>
-          </p:cNvPr>
-          <p:cNvPicPr>
-            <a:picLocks noChangeAspect="1"/>
-          </p:cNvPicPr>
-          <p:nvPr/>
-        </p:nvPicPr>
-        <p:blipFill>
-          <a:blip r:embed="rId8">
-            <a:extLst>
-              <a:ext uri="{28A0092B-C50C-407E-A947-70E740481C1C}">
-                <a14:useLocalDpi xmlns:a14="http://schemas.microsoft.com/office/drawing/2010/main" val="0"/>
-              </a:ext>
-              <a:ext uri="{837473B0-CC2E-450A-ABE3-18F120FF3D39}">
-                <a1611:picAttrSrcUrl xmlns:a1611="http://schemas.microsoft.com/office/drawing/2016/11/main" r:id="rId9"/>
-              </a:ext>
-            </a:extLst>
-          </a:blip>
-          <a:stretch>
-            <a:fillRect/>
-          </a:stretch>
-        </p:blipFill>
-        <p:spPr>
-          <a:xfrm>
-            <a:off x="4299827" y="2710689"/>
-            <a:ext cx="632780" cy="632780"/>
-          </a:xfrm>
-          <a:prstGeom prst="rect">
-            <a:avLst/>
-          </a:prstGeom>
-        </p:spPr>
-      </p:pic>
-      <p:pic>
-        <p:nvPicPr>
-          <p:cNvPr id="39" name="Picture 38" descr="File:Visual Studio Code 1.35 icon.svg - Wikimedia Commons">
-            <a:extLst>
-              <a:ext uri="{FF2B5EF4-FFF2-40B4-BE49-F238E27FC236}">
-                <a16:creationId xmlns:a16="http://schemas.microsoft.com/office/drawing/2014/main" id="{5DEE6865-6030-8BA1-FD5F-BAE0D64EEC63}"/>
-              </a:ext>
-            </a:extLst>
-          </p:cNvPr>
-          <p:cNvPicPr>
-            <a:picLocks noChangeAspect="1"/>
-          </p:cNvPicPr>
-          <p:nvPr/>
-        </p:nvPicPr>
-        <p:blipFill>
-          <a:blip r:embed="rId10"/>
           <a:stretch>
             <a:fillRect/>
           </a:stretch>
@@ -4367,7 +4333,7 @@
           <p:nvPr/>
         </p:nvPicPr>
         <p:blipFill>
-          <a:blip r:embed="rId11"/>
+          <a:blip r:embed="rId8"/>
           <a:stretch>
             <a:fillRect/>
           </a:stretch>
@@ -4397,7 +4363,7 @@
           <p:nvPr/>
         </p:nvPicPr>
         <p:blipFill>
-          <a:blip r:embed="rId12"/>
+          <a:blip r:embed="rId9"/>
           <a:stretch>
             <a:fillRect/>
           </a:stretch>
@@ -4427,7 +4393,7 @@
           <p:nvPr/>
         </p:nvPicPr>
         <p:blipFill>
-          <a:blip r:embed="rId13"/>
+          <a:blip r:embed="rId10"/>
           <a:stretch>
             <a:fillRect/>
           </a:stretch>
@@ -4457,7 +4423,7 @@
           <p:nvPr/>
         </p:nvPicPr>
         <p:blipFill>
-          <a:blip r:embed="rId14"/>
+          <a:blip r:embed="rId11"/>
           <a:srcRect l="22561" r="22556" b="30151"/>
           <a:stretch>
             <a:fillRect/>
@@ -4524,11 +4490,11 @@
           <p:nvPr/>
         </p:nvPicPr>
         <p:blipFill>
-          <a:blip r:embed="rId15">
+          <a:blip r:embed="rId12">
             <a:extLst>
               <a:ext uri="{BEBA8EAE-BF5A-486C-A8C5-ECC9F3942E4B}">
                 <a14:imgProps xmlns:a14="http://schemas.microsoft.com/office/drawing/2010/main">
-                  <a14:imgLayer r:embed="rId16">
+                  <a14:imgLayer r:embed="rId13">
                     <a14:imgEffect>
                       <a14:backgroundRemoval t="10000" b="90000" l="10000" r="90000"/>
                     </a14:imgEffect>
@@ -4539,7 +4505,7 @@
                 <a14:useLocalDpi xmlns:a14="http://schemas.microsoft.com/office/drawing/2010/main" val="0"/>
               </a:ext>
               <a:ext uri="{837473B0-CC2E-450A-ABE3-18F120FF3D39}">
-                <a1611:picAttrSrcUrl xmlns:a1611="http://schemas.microsoft.com/office/drawing/2016/11/main" r:id="rId17"/>
+                <a1611:picAttrSrcUrl xmlns:a1611="http://schemas.microsoft.com/office/drawing/2016/11/main" r:id="rId14"/>
               </a:ext>
             </a:extLst>
           </a:blip>
@@ -4712,13 +4678,13 @@
           <p:nvPr/>
         </p:nvPicPr>
         <p:blipFill>
-          <a:blip r:embed="rId18">
+          <a:blip r:embed="rId15">
             <a:extLst>
               <a:ext uri="{28A0092B-C50C-407E-A947-70E740481C1C}">
                 <a14:useLocalDpi xmlns:a14="http://schemas.microsoft.com/office/drawing/2010/main" val="0"/>
               </a:ext>
               <a:ext uri="{837473B0-CC2E-450A-ABE3-18F120FF3D39}">
-                <a1611:picAttrSrcUrl xmlns:a1611="http://schemas.microsoft.com/office/drawing/2016/11/main" r:id="rId19"/>
+                <a1611:picAttrSrcUrl xmlns:a1611="http://schemas.microsoft.com/office/drawing/2016/11/main" r:id="rId16"/>
               </a:ext>
             </a:extLst>
           </a:blip>

</xml_diff>